<commit_message>
Kapitola 5: autorovy úpravy prezentace a PDF
Ruční úpravy slidů 10, 25, 26, 28, 30 a 31 (poznámky beze změny, DOCX
proto zůstává v souladu) a PDF export prezentace.

Co-Authored-By: Claude Opus 5.5 <noreply@anthropic.com>
</commit_message>
<xml_diff>
--- a/presentations/kapitola_05_pravdepodobnost.pptx
+++ b/presentations/kapitola_05_pravdepodobnost.pptx
@@ -9628,52 +9628,14 @@
         </p:blipFill>
         <p:spPr>
           <a:xfrm>
-            <a:off x="3295051" y="3990975"/>
-            <a:ext cx="8649897" cy="3629025"/>
+            <a:off x="2159894" y="3671888"/>
+            <a:ext cx="11680765" cy="4900612"/>
           </a:xfrm>
           <a:prstGeom prst="rect">
             <a:avLst/>
           </a:prstGeom>
         </p:spPr>
       </p:pic>
-      <p:sp>
-        <p:nvSpPr>
-          <p:cNvPr id="16" name="Text 16"/>
-          <p:cNvSpPr txBox="1"/>
-          <p:nvPr/>
-        </p:nvSpPr>
-        <p:spPr>
-          <a:xfrm>
-            <a:off x="838200" y="7696200"/>
-            <a:ext cx="12382500" cy="285750"/>
-          </a:xfrm>
-          <a:prstGeom prst="rect">
-            <a:avLst/>
-          </a:prstGeom>
-          <a:noFill/>
-        </p:spPr>
-        <p:txBody>
-          <a:bodyPr wrap="square" lIns="0" tIns="0" rIns="0" bIns="0" anchor="t">
-            <a:noAutofit/>
-          </a:bodyPr>
-          <a:lstStyle/>
-          <a:p>
-            <a:pPr algn="l"/>
-            <a:r>
-              <a:rPr lang="cs-CZ" altLang="cs-CZ" sz="1650" b="0" noProof="0">
-                <a:solidFill>
-                  <a:srgbClr val="576574"/>
-                </a:solidFill>
-                <a:latin typeface="Arial"/>
-                <a:ea typeface="Arial"/>
-                <a:cs typeface="Arial"/>
-              </a:rPr>
-              <a:t>Modelový soubor 200 studentů</a:t>
-            </a:r>
-            <a:endParaRPr lang="cs-CZ" altLang="cs-CZ" sz="1650" noProof="0"/>
-          </a:p>
-        </p:txBody>
-      </p:sp>
       <p:sp>
         <p:nvSpPr>
           <p:cNvPr id="17" name="Text 17"/>
@@ -13496,8 +13458,8 @@
         </p:blipFill>
         <p:spPr>
           <a:xfrm>
-            <a:off x="2875043" y="3638550"/>
-            <a:ext cx="9489913" cy="3981450"/>
+            <a:off x="2595619" y="3638550"/>
+            <a:ext cx="10048761" cy="4215912"/>
           </a:xfrm>
           <a:prstGeom prst="rect">
             <a:avLst/>
@@ -13512,7 +13474,7 @@
         </p:nvSpPr>
         <p:spPr>
           <a:xfrm>
-            <a:off x="838200" y="7696200"/>
+            <a:off x="838200" y="8035437"/>
             <a:ext cx="12382500" cy="285750"/>
           </a:xfrm>
           <a:prstGeom prst="rect">
@@ -13528,7 +13490,7 @@
           <a:p>
             <a:pPr algn="l"/>
             <a:r>
-              <a:rPr lang="cs-CZ" altLang="cs-CZ" sz="1650" b="0" noProof="0">
+              <a:rPr lang="cs-CZ" altLang="cs-CZ" sz="1650" b="0" noProof="0" dirty="0">
                 <a:solidFill>
                   <a:srgbClr val="576574"/>
                 </a:solidFill>
@@ -13538,7 +13500,7 @@
               </a:rPr>
               <a:t>Vlevo druhý modelový soubor (nezávislost), vpravo původní soubor (závislost)</a:t>
             </a:r>
-            <a:endParaRPr lang="cs-CZ" altLang="cs-CZ" sz="1650" noProof="0"/>
+            <a:endParaRPr lang="cs-CZ" altLang="cs-CZ" sz="1650" noProof="0" dirty="0"/>
           </a:p>
         </p:txBody>
       </p:sp>
@@ -14942,7 +14904,7 @@
           <a:p>
             <a:pPr algn="l"/>
             <a:r>
-              <a:rPr lang="cs-CZ" altLang="cs-CZ" sz="2850" b="1" noProof="0">
+              <a:rPr lang="cs-CZ" altLang="cs-CZ" sz="2850" b="1" noProof="0" dirty="0">
                 <a:solidFill>
                   <a:srgbClr val="142A3B"/>
                 </a:solidFill>
@@ -14953,7 +14915,7 @@
               <a:t>Senzitivita</a:t>
             </a:r>
             <a:r>
-              <a:rPr lang="cs-CZ" altLang="cs-CZ" sz="2850" b="0" noProof="0">
+              <a:rPr lang="cs-CZ" altLang="cs-CZ" sz="2850" b="0" noProof="0" dirty="0">
                 <a:solidFill>
                   <a:srgbClr val="142A3B"/>
                 </a:solidFill>
@@ -14964,7 +14926,7 @@
               <a:t> </a:t>
             </a:r>
             <a:r>
-              <a:rPr lang="cs-CZ" altLang="cs-CZ" sz="2850" b="0" i="1" noProof="0">
+              <a:rPr lang="cs-CZ" altLang="cs-CZ" sz="2850" b="0" i="1" noProof="0" dirty="0">
                 <a:solidFill>
                   <a:srgbClr val="142A3B"/>
                 </a:solidFill>
@@ -14975,7 +14937,7 @@
               <a:t>P</a:t>
             </a:r>
             <a:r>
-              <a:rPr lang="cs-CZ" altLang="cs-CZ" sz="2850" b="0" noProof="0">
+              <a:rPr lang="cs-CZ" altLang="cs-CZ" sz="2850" b="0" noProof="0" dirty="0">
                 <a:solidFill>
                   <a:srgbClr val="142A3B"/>
                 </a:solidFill>
@@ -14985,8 +14947,18 @@
               </a:rPr>
               <a:t>(pozitivní | porucha) = 0,95; </a:t>
             </a:r>
-            <a:r>
-              <a:rPr lang="cs-CZ" altLang="cs-CZ" sz="2850" b="1" noProof="0">
+            <a:br>
+              <a:rPr lang="cs-CZ" altLang="cs-CZ" sz="2850" b="0" noProof="0" dirty="0">
+                <a:solidFill>
+                  <a:srgbClr val="142A3B"/>
+                </a:solidFill>
+                <a:latin typeface="Arial"/>
+                <a:ea typeface="Arial"/>
+                <a:cs typeface="Arial"/>
+              </a:rPr>
+            </a:br>
+            <a:r>
+              <a:rPr lang="cs-CZ" altLang="cs-CZ" sz="2850" b="1" noProof="0" dirty="0">
                 <a:solidFill>
                   <a:srgbClr val="142A3B"/>
                 </a:solidFill>
@@ -14997,7 +14969,7 @@
               <a:t>specificita</a:t>
             </a:r>
             <a:r>
-              <a:rPr lang="cs-CZ" altLang="cs-CZ" sz="2850" b="0" noProof="0">
+              <a:rPr lang="cs-CZ" altLang="cs-CZ" sz="2850" b="0" noProof="0" dirty="0">
                 <a:solidFill>
                   <a:srgbClr val="142A3B"/>
                 </a:solidFill>
@@ -15008,7 +14980,7 @@
               <a:t> </a:t>
             </a:r>
             <a:r>
-              <a:rPr lang="cs-CZ" altLang="cs-CZ" sz="2850" b="0" i="1" noProof="0">
+              <a:rPr lang="cs-CZ" altLang="cs-CZ" sz="2850" b="0" i="1" noProof="0" dirty="0">
                 <a:solidFill>
                   <a:srgbClr val="142A3B"/>
                 </a:solidFill>
@@ -15019,7 +14991,7 @@
               <a:t>P</a:t>
             </a:r>
             <a:r>
-              <a:rPr lang="cs-CZ" altLang="cs-CZ" sz="2850" b="0" noProof="0">
+              <a:rPr lang="cs-CZ" altLang="cs-CZ" sz="2850" b="0" noProof="0" dirty="0">
                 <a:solidFill>
                   <a:srgbClr val="142A3B"/>
                 </a:solidFill>
@@ -15029,7 +15001,7 @@
               </a:rPr>
               <a:t>(negativní | bez poruchy) = 0,90</a:t>
             </a:r>
-            <a:endParaRPr lang="cs-CZ" altLang="cs-CZ" sz="2850" noProof="0"/>
+            <a:endParaRPr lang="cs-CZ" altLang="cs-CZ" sz="2850" noProof="0" dirty="0"/>
           </a:p>
         </p:txBody>
       </p:sp>
@@ -15316,8 +15288,8 @@
         </p:blipFill>
         <p:spPr>
           <a:xfrm>
-            <a:off x="5791200" y="2038483"/>
-            <a:ext cx="8610600" cy="5400408"/>
+            <a:off x="5380937" y="1512780"/>
+            <a:ext cx="9859063" cy="6183420"/>
           </a:xfrm>
           <a:prstGeom prst="rect">
             <a:avLst/>
@@ -16953,8 +16925,8 @@
         </p:blipFill>
         <p:spPr>
           <a:xfrm>
-            <a:off x="2705905" y="3038475"/>
-            <a:ext cx="9828190" cy="4581525"/>
+            <a:off x="2504720" y="3038475"/>
+            <a:ext cx="10230559" cy="4769094"/>
           </a:xfrm>
           <a:prstGeom prst="rect">
             <a:avLst/>
@@ -16969,7 +16941,7 @@
         </p:nvSpPr>
         <p:spPr>
           <a:xfrm>
-            <a:off x="838200" y="7696200"/>
+            <a:off x="838200" y="8001000"/>
             <a:ext cx="12382500" cy="285750"/>
           </a:xfrm>
           <a:prstGeom prst="rect">
@@ -16985,7 +16957,7 @@
           <a:p>
             <a:pPr algn="l"/>
             <a:r>
-              <a:rPr lang="cs-CZ" altLang="cs-CZ" sz="1650" b="0" noProof="0">
+              <a:rPr lang="cs-CZ" altLang="cs-CZ" sz="1650" b="0" noProof="0" dirty="0">
                 <a:solidFill>
                   <a:srgbClr val="576574"/>
                 </a:solidFill>
@@ -16995,7 +16967,7 @@
               </a:rPr>
               <a:t>Předpoklad: senzitivita 0,95 a specificita 0,90 v obou skupinách</a:t>
             </a:r>
-            <a:endParaRPr lang="cs-CZ" altLang="cs-CZ" sz="1650" noProof="0"/>
+            <a:endParaRPr lang="cs-CZ" altLang="cs-CZ" sz="1650" noProof="0" dirty="0"/>
           </a:p>
         </p:txBody>
       </p:sp>
@@ -17187,7 +17159,7 @@
         </p:nvSpPr>
         <p:spPr>
           <a:xfrm>
-            <a:off x="838200" y="571500"/>
+            <a:off x="838200" y="354623"/>
             <a:ext cx="13563600" cy="666750"/>
           </a:xfrm>
           <a:prstGeom prst="rect">
@@ -17203,7 +17175,7 @@
           <a:p>
             <a:pPr algn="l"/>
             <a:r>
-              <a:rPr lang="cs-CZ" altLang="cs-CZ" sz="3600" b="1" noProof="0">
+              <a:rPr lang="cs-CZ" altLang="cs-CZ" sz="3600" b="1" noProof="0" dirty="0">
                 <a:solidFill>
                   <a:srgbClr val="142A3B"/>
                 </a:solidFill>
@@ -17213,7 +17185,7 @@
               </a:rPr>
               <a:t>Náhodná proměnná přiřazuje výsledkům čísla</a:t>
             </a:r>
-            <a:endParaRPr lang="cs-CZ" altLang="cs-CZ" sz="3600" noProof="0"/>
+            <a:endParaRPr lang="cs-CZ" altLang="cs-CZ" sz="3600" noProof="0" dirty="0"/>
           </a:p>
         </p:txBody>
       </p:sp>
@@ -17233,8 +17205,8 @@
         </p:blipFill>
         <p:spPr>
           <a:xfrm>
-            <a:off x="7099102" y="1524000"/>
-            <a:ext cx="7233047" cy="6429375"/>
+            <a:off x="5645441" y="976863"/>
+            <a:ext cx="8410528" cy="7476025"/>
           </a:xfrm>
           <a:prstGeom prst="rect">
             <a:avLst/>
@@ -17336,7 +17308,7 @@
           <a:p>
             <a:pPr algn="l"/>
             <a:r>
-              <a:rPr lang="cs-CZ" altLang="cs-CZ" sz="2100" b="0" i="1" noProof="0">
+              <a:rPr lang="cs-CZ" altLang="cs-CZ" sz="2100" b="0" i="1" noProof="0" dirty="0">
                 <a:solidFill>
                   <a:srgbClr val="142A3B"/>
                 </a:solidFill>
@@ -17347,7 +17319,7 @@
               <a:t>X</a:t>
             </a:r>
             <a:r>
-              <a:rPr lang="cs-CZ" altLang="cs-CZ" sz="2100" b="0" noProof="0">
+              <a:rPr lang="cs-CZ" altLang="cs-CZ" sz="2100" b="0" noProof="0" dirty="0">
                 <a:solidFill>
                   <a:srgbClr val="142A3B"/>
                 </a:solidFill>
@@ -17357,8 +17329,18 @@
               </a:rPr>
               <a:t> = počet správných tipů; </a:t>
             </a:r>
-            <a:r>
-              <a:rPr lang="cs-CZ" altLang="cs-CZ" sz="2100" b="0" i="1" noProof="0">
+            <a:br>
+              <a:rPr lang="cs-CZ" altLang="cs-CZ" sz="2100" b="0" noProof="0" dirty="0">
+                <a:solidFill>
+                  <a:srgbClr val="142A3B"/>
+                </a:solidFill>
+                <a:latin typeface="Arial"/>
+                <a:ea typeface="Arial"/>
+                <a:cs typeface="Arial"/>
+              </a:rPr>
+            </a:br>
+            <a:r>
+              <a:rPr lang="cs-CZ" altLang="cs-CZ" sz="2100" b="0" i="1" noProof="0" dirty="0">
                 <a:solidFill>
                   <a:srgbClr val="142A3B"/>
                 </a:solidFill>
@@ -17369,7 +17351,7 @@
               <a:t>k</a:t>
             </a:r>
             <a:r>
-              <a:rPr lang="cs-CZ" altLang="cs-CZ" sz="2100" b="0" noProof="0">
+              <a:rPr lang="cs-CZ" altLang="cs-CZ" sz="2100" b="0" noProof="0" dirty="0">
                 <a:solidFill>
                   <a:srgbClr val="142A3B"/>
                 </a:solidFill>
@@ -17379,7 +17361,7 @@
               </a:rPr>
               <a:t> = konkrétní hodnota</a:t>
             </a:r>
-            <a:endParaRPr lang="cs-CZ" altLang="cs-CZ" sz="2100" noProof="0"/>
+            <a:endParaRPr lang="cs-CZ" altLang="cs-CZ" sz="2100" noProof="0" dirty="0"/>
           </a:p>
         </p:txBody>
       </p:sp>
@@ -17407,7 +17389,7 @@
           <a:p>
             <a:pPr algn="l"/>
             <a:r>
-              <a:rPr lang="cs-CZ" altLang="cs-CZ" sz="2100" b="0" noProof="0">
+              <a:rPr lang="cs-CZ" altLang="cs-CZ" sz="2100" b="0" noProof="0" dirty="0">
                 <a:solidFill>
                   <a:srgbClr val="142A3B"/>
                 </a:solidFill>
@@ -17418,7 +17400,7 @@
               <a:t>Hodnota </a:t>
             </a:r>
             <a:r>
-              <a:rPr lang="cs-CZ" altLang="cs-CZ" sz="2100" b="0" i="1" noProof="0">
+              <a:rPr lang="cs-CZ" altLang="cs-CZ" sz="2100" b="0" i="1" noProof="0" dirty="0">
                 <a:solidFill>
                   <a:srgbClr val="142A3B"/>
                 </a:solidFill>
@@ -17429,17 +17411,38 @@
               <a:t>X</a:t>
             </a:r>
             <a:r>
-              <a:rPr lang="cs-CZ" altLang="cs-CZ" sz="2100" b="0" noProof="0">
-                <a:solidFill>
-                  <a:srgbClr val="142A3B"/>
-                </a:solidFill>
-                <a:latin typeface="Arial"/>
-                <a:ea typeface="Arial"/>
-                <a:cs typeface="Arial"/>
-              </a:rPr>
-              <a:t> = 1 je jev: výsledky NS a SN</a:t>
-            </a:r>
-            <a:endParaRPr lang="cs-CZ" altLang="cs-CZ" sz="2100" noProof="0"/>
+              <a:rPr lang="cs-CZ" altLang="cs-CZ" sz="2100" b="0" noProof="0" dirty="0">
+                <a:solidFill>
+                  <a:srgbClr val="142A3B"/>
+                </a:solidFill>
+                <a:latin typeface="Arial"/>
+                <a:ea typeface="Arial"/>
+                <a:cs typeface="Arial"/>
+              </a:rPr>
+              <a:t> = 1 je jev: </a:t>
+            </a:r>
+            <a:br>
+              <a:rPr lang="cs-CZ" altLang="cs-CZ" sz="2100" b="0" noProof="0" dirty="0">
+                <a:solidFill>
+                  <a:srgbClr val="142A3B"/>
+                </a:solidFill>
+                <a:latin typeface="Arial"/>
+                <a:ea typeface="Arial"/>
+                <a:cs typeface="Arial"/>
+              </a:rPr>
+            </a:br>
+            <a:r>
+              <a:rPr lang="cs-CZ" altLang="cs-CZ" sz="2100" b="0" noProof="0" dirty="0">
+                <a:solidFill>
+                  <a:srgbClr val="142A3B"/>
+                </a:solidFill>
+                <a:latin typeface="Arial"/>
+                <a:ea typeface="Arial"/>
+                <a:cs typeface="Arial"/>
+              </a:rPr>
+              <a:t>výsledky NS a SN</a:t>
+            </a:r>
+            <a:endParaRPr lang="cs-CZ" altLang="cs-CZ" sz="2100" noProof="0" dirty="0"/>
           </a:p>
         </p:txBody>
       </p:sp>
@@ -17451,7 +17454,7 @@
         </p:nvSpPr>
         <p:spPr>
           <a:xfrm>
-            <a:off x="838200" y="4105275"/>
+            <a:off x="838200" y="4480413"/>
             <a:ext cx="5715000" cy="657225"/>
           </a:xfrm>
           <a:prstGeom prst="rect">
@@ -17467,7 +17470,7 @@
           <a:p>
             <a:pPr algn="l"/>
             <a:r>
-              <a:rPr lang="cs-CZ" altLang="cs-CZ" sz="2100" b="1" noProof="0">
+              <a:rPr lang="cs-CZ" altLang="cs-CZ" sz="2100" b="1" noProof="0" dirty="0">
                 <a:solidFill>
                   <a:srgbClr val="142A3B"/>
                 </a:solidFill>
@@ -17478,7 +17481,7 @@
               <a:t>Rozdělení pravděpodobnosti:</a:t>
             </a:r>
             <a:r>
-              <a:rPr lang="cs-CZ" altLang="cs-CZ" sz="2100" b="0" noProof="0">
+              <a:rPr lang="cs-CZ" altLang="cs-CZ" sz="2100" b="0" noProof="0" dirty="0">
                 <a:solidFill>
                   <a:srgbClr val="142A3B"/>
                 </a:solidFill>
@@ -17488,8 +17491,18 @@
               </a:rPr>
               <a:t> </a:t>
             </a:r>
-            <a:r>
-              <a:rPr lang="cs-CZ" altLang="cs-CZ" sz="2100" b="0" i="1" noProof="0">
+            <a:br>
+              <a:rPr lang="cs-CZ" altLang="cs-CZ" sz="2100" b="0" noProof="0" dirty="0">
+                <a:solidFill>
+                  <a:srgbClr val="142A3B"/>
+                </a:solidFill>
+                <a:latin typeface="Arial"/>
+                <a:ea typeface="Arial"/>
+                <a:cs typeface="Arial"/>
+              </a:rPr>
+            </a:br>
+            <a:r>
+              <a:rPr lang="cs-CZ" altLang="cs-CZ" sz="2100" b="0" i="1" noProof="0" dirty="0">
                 <a:solidFill>
                   <a:srgbClr val="142A3B"/>
                 </a:solidFill>
@@ -17500,7 +17513,7 @@
               <a:t>P</a:t>
             </a:r>
             <a:r>
-              <a:rPr lang="cs-CZ" altLang="cs-CZ" sz="2100" b="0" noProof="0">
+              <a:rPr lang="cs-CZ" altLang="cs-CZ" sz="2100" b="0" noProof="0" dirty="0">
                 <a:solidFill>
                   <a:srgbClr val="142A3B"/>
                 </a:solidFill>
@@ -17511,7 +17524,7 @@
               <a:t>(</a:t>
             </a:r>
             <a:r>
-              <a:rPr lang="cs-CZ" altLang="cs-CZ" sz="2100" b="0" i="1" noProof="0">
+              <a:rPr lang="cs-CZ" altLang="cs-CZ" sz="2100" b="0" i="1" noProof="0" dirty="0">
                 <a:solidFill>
                   <a:srgbClr val="142A3B"/>
                 </a:solidFill>
@@ -17522,7 +17535,7 @@
               <a:t>X</a:t>
             </a:r>
             <a:r>
-              <a:rPr lang="cs-CZ" altLang="cs-CZ" sz="2100" b="0" noProof="0">
+              <a:rPr lang="cs-CZ" altLang="cs-CZ" sz="2100" b="0" noProof="0" dirty="0">
                 <a:solidFill>
                   <a:srgbClr val="142A3B"/>
                 </a:solidFill>
@@ -17533,7 +17546,7 @@
               <a:t> = </a:t>
             </a:r>
             <a:r>
-              <a:rPr lang="cs-CZ" altLang="cs-CZ" sz="2100" b="0" i="1" noProof="0">
+              <a:rPr lang="cs-CZ" altLang="cs-CZ" sz="2100" b="0" i="1" noProof="0" dirty="0">
                 <a:solidFill>
                   <a:srgbClr val="142A3B"/>
                 </a:solidFill>
@@ -17544,7 +17557,7 @@
               <a:t>k</a:t>
             </a:r>
             <a:r>
-              <a:rPr lang="cs-CZ" altLang="cs-CZ" sz="2100" b="0" noProof="0">
+              <a:rPr lang="cs-CZ" altLang="cs-CZ" sz="2100" b="0" noProof="0" dirty="0">
                 <a:solidFill>
                   <a:srgbClr val="142A3B"/>
                 </a:solidFill>
@@ -17554,7 +17567,7 @@
               </a:rPr>
               <a:t>) pro všechny hodnoty, součet 1</a:t>
             </a:r>
-            <a:endParaRPr lang="cs-CZ" altLang="cs-CZ" sz="2100" noProof="0"/>
+            <a:endParaRPr lang="cs-CZ" altLang="cs-CZ" sz="2100" noProof="0" dirty="0"/>
           </a:p>
         </p:txBody>
       </p:sp>
@@ -17566,7 +17579,7 @@
         </p:nvSpPr>
         <p:spPr>
           <a:xfrm>
-            <a:off x="838200" y="5010150"/>
+            <a:off x="838200" y="5385288"/>
             <a:ext cx="5715000" cy="333375"/>
           </a:xfrm>
           <a:prstGeom prst="rect">
@@ -17582,17 +17595,38 @@
           <a:p>
             <a:pPr algn="l"/>
             <a:r>
-              <a:rPr lang="cs-CZ" altLang="cs-CZ" sz="2100" b="0" noProof="0">
-                <a:solidFill>
-                  <a:srgbClr val="142A3B"/>
-                </a:solidFill>
-                <a:latin typeface="Arial"/>
-                <a:ea typeface="Arial"/>
-                <a:cs typeface="Arial"/>
-              </a:rPr>
-              <a:t>Není to sloupec dat a nevyžaduje opakování</a:t>
-            </a:r>
-            <a:endParaRPr lang="cs-CZ" altLang="cs-CZ" sz="2100" noProof="0"/>
+              <a:rPr lang="cs-CZ" altLang="cs-CZ" sz="2100" b="0" noProof="0" dirty="0">
+                <a:solidFill>
+                  <a:srgbClr val="142A3B"/>
+                </a:solidFill>
+                <a:latin typeface="Arial"/>
+                <a:ea typeface="Arial"/>
+                <a:cs typeface="Arial"/>
+              </a:rPr>
+              <a:t>Není to sloupec dat </a:t>
+            </a:r>
+            <a:br>
+              <a:rPr lang="cs-CZ" altLang="cs-CZ" sz="2100" b="0" noProof="0" dirty="0">
+                <a:solidFill>
+                  <a:srgbClr val="142A3B"/>
+                </a:solidFill>
+                <a:latin typeface="Arial"/>
+                <a:ea typeface="Arial"/>
+                <a:cs typeface="Arial"/>
+              </a:rPr>
+            </a:br>
+            <a:r>
+              <a:rPr lang="cs-CZ" altLang="cs-CZ" sz="2100" b="0" noProof="0" dirty="0">
+                <a:solidFill>
+                  <a:srgbClr val="142A3B"/>
+                </a:solidFill>
+                <a:latin typeface="Arial"/>
+                <a:ea typeface="Arial"/>
+                <a:cs typeface="Arial"/>
+              </a:rPr>
+              <a:t>a nevyžaduje opakování</a:t>
+            </a:r>
+            <a:endParaRPr lang="cs-CZ" altLang="cs-CZ" sz="2100" noProof="0" dirty="0"/>
           </a:p>
         </p:txBody>
       </p:sp>
@@ -17868,52 +17902,14 @@
         </p:blipFill>
         <p:spPr>
           <a:xfrm>
-            <a:off x="2402943" y="3038475"/>
-            <a:ext cx="10434115" cy="4581525"/>
+            <a:off x="1112236" y="3038474"/>
+            <a:ext cx="12603369" cy="5534025"/>
           </a:xfrm>
           <a:prstGeom prst="rect">
             <a:avLst/>
           </a:prstGeom>
         </p:spPr>
       </p:pic>
-      <p:sp>
-        <p:nvSpPr>
-          <p:cNvPr id="16" name="Text 16"/>
-          <p:cNvSpPr txBox="1"/>
-          <p:nvPr/>
-        </p:nvSpPr>
-        <p:spPr>
-          <a:xfrm>
-            <a:off x="838200" y="7696200"/>
-            <a:ext cx="12382500" cy="285750"/>
-          </a:xfrm>
-          <a:prstGeom prst="rect">
-            <a:avLst/>
-          </a:prstGeom>
-          <a:noFill/>
-        </p:spPr>
-        <p:txBody>
-          <a:bodyPr wrap="square" lIns="0" tIns="0" rIns="0" bIns="0" anchor="t">
-            <a:noAutofit/>
-          </a:bodyPr>
-          <a:lstStyle/>
-          <a:p>
-            <a:pPr algn="l"/>
-            <a:r>
-              <a:rPr lang="cs-CZ" altLang="cs-CZ" sz="1650" b="0" noProof="0">
-                <a:solidFill>
-                  <a:srgbClr val="576574"/>
-                </a:solidFill>
-                <a:latin typeface="Arial"/>
-                <a:ea typeface="Arial"/>
-                <a:cs typeface="Arial"/>
-              </a:rPr>
-              <a:t>Data vpravo jsou simulovaná</a:t>
-            </a:r>
-            <a:endParaRPr lang="cs-CZ" altLang="cs-CZ" sz="1650" noProof="0"/>
-          </a:p>
-        </p:txBody>
-      </p:sp>
       <p:sp>
         <p:nvSpPr>
           <p:cNvPr id="17" name="Text 17"/>
@@ -18530,16 +18526,16 @@
         </p:blipFill>
         <p:spPr>
           <a:xfrm>
-            <a:off x="8553450" y="3108819"/>
-            <a:ext cx="5848350" cy="3259736"/>
+            <a:off x="5010667" y="1420107"/>
+            <a:ext cx="10229333" cy="5701595"/>
           </a:xfrm>
           <a:prstGeom prst="rect">
             <a:avLst/>
           </a:prstGeom>
         </p:spPr>
       </p:pic>
-      <mc:AlternateContent xmlns:mc="http://schemas.openxmlformats.org/markup-compatibility/2006" xmlns:a14="http://schemas.microsoft.com/office/drawing/2010/main">
-        <mc:Choice Requires="a14">
+      <mc:AlternateContent xmlns:mc="http://schemas.openxmlformats.org/markup-compatibility/2006">
+        <mc:Choice xmlns:a14="http://schemas.microsoft.com/office/drawing/2010/main" Requires="a14">
           <p:sp>
             <p:nvSpPr>
               <p:cNvPr id="13" name="Vzorec 13" descr="(n nad k) = n! / [k! × (n − k)!]"/>
@@ -18718,16 +18714,18 @@
                     </m:oMath>
                   </m:oMathPara>
                 </a14:m>
-                <a:endParaRPr lang="cs-CZ" altLang="cs-CZ" sz="2925" noProof="0"/>
+                <a:endParaRPr lang="cs-CZ" altLang="cs-CZ" sz="2925" noProof="0" dirty="0"/>
               </a:p>
             </p:txBody>
           </p:sp>
         </mc:Choice>
-        <mc:Fallback xmlns="">
+        <mc:Fallback>
           <p:sp>
             <p:nvSpPr>
               <p:cNvPr id="13" name="Vzorec 13" descr="(n nad k) = n! / [k! × (n − k)!]"/>
-              <p:cNvSpPr txBox="1"/>
+              <p:cNvSpPr txBox="1">
+                <a:spLocks noRot="1" noChangeAspect="1" noMove="1" noResize="1" noEditPoints="1" noAdjustHandles="1" noChangeArrowheads="1" noChangeShapeType="1" noTextEdit="1"/>
+              </p:cNvSpPr>
               <p:nvPr/>
             </p:nvSpPr>
             <p:spPr>
@@ -18738,27 +18736,23 @@
               <a:prstGeom prst="rect">
                 <a:avLst/>
               </a:prstGeom>
-              <a:noFill/>
+              <a:blipFill>
+                <a:blip r:embed="rId4"/>
+                <a:stretch>
+                  <a:fillRect/>
+                </a:stretch>
+              </a:blipFill>
             </p:spPr>
             <p:txBody>
-              <a:bodyPr wrap="square" lIns="0" tIns="0" rIns="0" bIns="0" anchor="ctr">
-                <a:noAutofit/>
-              </a:bodyPr>
+              <a:bodyPr/>
               <a:lstStyle/>
               <a:p>
-                <a:pPr algn="l"/>
                 <a:r>
-                  <a:rPr lang="cs-CZ" altLang="cs-CZ" sz="2550" b="0" noProof="0">
-                    <a:solidFill>
-                      <a:srgbClr val="142A3B"/>
-                    </a:solidFill>
-                    <a:latin typeface="Arial"/>
-                    <a:ea typeface="Arial"/>
-                    <a:cs typeface="Arial"/>
+                  <a:rPr lang="cs-CZ">
+                    <a:noFill/>
                   </a:rPr>
-                  <a:t xml:space="preserve">(n nad k) = n! / [k! × (n − k)!]</a:t>
+                  <a:t> </a:t>
                 </a:r>
-                <a:endParaRPr lang="cs-CZ" altLang="cs-CZ" sz="2550" noProof="0"/>
               </a:p>
             </p:txBody>
           </p:sp>
@@ -18772,7 +18766,7 @@
         </p:nvSpPr>
         <p:spPr>
           <a:xfrm>
-            <a:off x="838200" y="3009900"/>
+            <a:off x="838200" y="3154889"/>
             <a:ext cx="7239000" cy="390525"/>
           </a:xfrm>
           <a:prstGeom prst="rect">
@@ -18788,18 +18782,39 @@
           <a:p>
             <a:pPr algn="l"/>
             <a:r>
-              <a:rPr lang="cs-CZ" altLang="cs-CZ" sz="2475" b="0" noProof="0">
-                <a:solidFill>
-                  <a:srgbClr val="142A3B"/>
-                </a:solidFill>
-                <a:latin typeface="Arial"/>
-                <a:ea typeface="Arial"/>
-                <a:cs typeface="Arial"/>
-              </a:rPr>
-              <a:t>Dvě správné otázky z pěti: (5 × 4) / 2 = </a:t>
-            </a:r>
-            <a:r>
-              <a:rPr lang="cs-CZ" altLang="cs-CZ" sz="2475" b="1" noProof="0">
+              <a:rPr lang="cs-CZ" altLang="cs-CZ" sz="2475" b="0" noProof="0" dirty="0">
+                <a:solidFill>
+                  <a:srgbClr val="142A3B"/>
+                </a:solidFill>
+                <a:latin typeface="Arial"/>
+                <a:ea typeface="Arial"/>
+                <a:cs typeface="Arial"/>
+              </a:rPr>
+              <a:t>Dvě správné otázky z pěti: </a:t>
+            </a:r>
+            <a:br>
+              <a:rPr lang="cs-CZ" altLang="cs-CZ" sz="2475" b="0" noProof="0" dirty="0">
+                <a:solidFill>
+                  <a:srgbClr val="142A3B"/>
+                </a:solidFill>
+                <a:latin typeface="Arial"/>
+                <a:ea typeface="Arial"/>
+                <a:cs typeface="Arial"/>
+              </a:rPr>
+            </a:br>
+            <a:r>
+              <a:rPr lang="cs-CZ" altLang="cs-CZ" sz="2475" b="0" noProof="0" dirty="0">
+                <a:solidFill>
+                  <a:srgbClr val="142A3B"/>
+                </a:solidFill>
+                <a:latin typeface="Arial"/>
+                <a:ea typeface="Arial"/>
+                <a:cs typeface="Arial"/>
+              </a:rPr>
+              <a:t>(5 × 4) / 2 = </a:t>
+            </a:r>
+            <a:r>
+              <a:rPr lang="cs-CZ" altLang="cs-CZ" sz="2475" b="1" noProof="0" dirty="0">
                 <a:solidFill>
                   <a:srgbClr val="142A3B"/>
                 </a:solidFill>
@@ -18809,7 +18824,7 @@
               </a:rPr>
               <a:t>10</a:t>
             </a:r>
-            <a:endParaRPr lang="cs-CZ" altLang="cs-CZ" sz="2475" noProof="0"/>
+            <a:endParaRPr lang="cs-CZ" altLang="cs-CZ" sz="2475" noProof="0" dirty="0"/>
           </a:p>
         </p:txBody>
       </p:sp>
@@ -18821,8 +18836,8 @@
         </p:nvSpPr>
         <p:spPr>
           <a:xfrm>
-            <a:off x="838200" y="3648075"/>
-            <a:ext cx="7239000" cy="771525"/>
+            <a:off x="838200" y="4605698"/>
+            <a:ext cx="7239000" cy="1551842"/>
           </a:xfrm>
           <a:prstGeom prst="rect">
             <a:avLst/>
@@ -18837,7 +18852,7 @@
           <a:p>
             <a:pPr algn="l"/>
             <a:r>
-              <a:rPr lang="cs-CZ" altLang="cs-CZ" sz="2475" b="0" noProof="0">
+              <a:rPr lang="cs-CZ" altLang="cs-CZ" sz="2475" b="0" noProof="0" dirty="0">
                 <a:solidFill>
                   <a:srgbClr val="142A3B"/>
                 </a:solidFill>
@@ -18848,7 +18863,7 @@
               <a:t>Faktoriál </a:t>
             </a:r>
             <a:r>
-              <a:rPr lang="cs-CZ" altLang="cs-CZ" sz="2475" b="0" i="1" noProof="0">
+              <a:rPr lang="cs-CZ" altLang="cs-CZ" sz="2475" b="0" i="1" noProof="0" dirty="0">
                 <a:solidFill>
                   <a:srgbClr val="142A3B"/>
                 </a:solidFill>
@@ -18859,7 +18874,7 @@
               <a:t>n</a:t>
             </a:r>
             <a:r>
-              <a:rPr lang="cs-CZ" altLang="cs-CZ" sz="2475" b="0" noProof="0">
+              <a:rPr lang="cs-CZ" altLang="cs-CZ" sz="2475" b="0" noProof="0" dirty="0">
                 <a:solidFill>
                   <a:srgbClr val="142A3B"/>
                 </a:solidFill>
@@ -18869,8 +18884,18 @@
               </a:rPr>
               <a:t>! = </a:t>
             </a:r>
-            <a:r>
-              <a:rPr lang="cs-CZ" altLang="cs-CZ" sz="2475" b="0" i="1" noProof="0">
+            <a:br>
+              <a:rPr lang="cs-CZ" altLang="cs-CZ" sz="2475" b="0" noProof="0" dirty="0">
+                <a:solidFill>
+                  <a:srgbClr val="142A3B"/>
+                </a:solidFill>
+                <a:latin typeface="Arial"/>
+                <a:ea typeface="Arial"/>
+                <a:cs typeface="Arial"/>
+              </a:rPr>
+            </a:br>
+            <a:r>
+              <a:rPr lang="cs-CZ" altLang="cs-CZ" sz="2475" b="0" i="1" noProof="0" dirty="0">
                 <a:solidFill>
                   <a:srgbClr val="142A3B"/>
                 </a:solidFill>
@@ -18881,7 +18906,7 @@
               <a:t>n</a:t>
             </a:r>
             <a:r>
-              <a:rPr lang="cs-CZ" altLang="cs-CZ" sz="2475" b="0" noProof="0">
+              <a:rPr lang="cs-CZ" altLang="cs-CZ" sz="2475" b="0" noProof="0" dirty="0">
                 <a:solidFill>
                   <a:srgbClr val="142A3B"/>
                 </a:solidFill>
@@ -18892,7 +18917,7 @@
               <a:t> × (</a:t>
             </a:r>
             <a:r>
-              <a:rPr lang="cs-CZ" altLang="cs-CZ" sz="2475" b="0" i="1" noProof="0">
+              <a:rPr lang="cs-CZ" altLang="cs-CZ" sz="2475" b="0" i="1" noProof="0" dirty="0">
                 <a:solidFill>
                   <a:srgbClr val="142A3B"/>
                 </a:solidFill>
@@ -18903,17 +18928,38 @@
               <a:t>n</a:t>
             </a:r>
             <a:r>
-              <a:rPr lang="cs-CZ" altLang="cs-CZ" sz="2475" b="0" noProof="0">
-                <a:solidFill>
-                  <a:srgbClr val="142A3B"/>
-                </a:solidFill>
-                <a:latin typeface="Arial"/>
-                <a:ea typeface="Arial"/>
-                <a:cs typeface="Arial"/>
-              </a:rPr>
-              <a:t> − 1) × … × 1; 5! = 120, 0! = 1</a:t>
-            </a:r>
-            <a:endParaRPr lang="cs-CZ" altLang="cs-CZ" sz="2475" noProof="0"/>
+              <a:rPr lang="cs-CZ" altLang="cs-CZ" sz="2475" b="0" noProof="0" dirty="0">
+                <a:solidFill>
+                  <a:srgbClr val="142A3B"/>
+                </a:solidFill>
+                <a:latin typeface="Arial"/>
+                <a:ea typeface="Arial"/>
+                <a:cs typeface="Arial"/>
+              </a:rPr>
+              <a:t> − 1) × … × 1; </a:t>
+            </a:r>
+            <a:br>
+              <a:rPr lang="cs-CZ" altLang="cs-CZ" sz="2475" b="0" noProof="0" dirty="0">
+                <a:solidFill>
+                  <a:srgbClr val="142A3B"/>
+                </a:solidFill>
+                <a:latin typeface="Arial"/>
+                <a:ea typeface="Arial"/>
+                <a:cs typeface="Arial"/>
+              </a:rPr>
+            </a:br>
+            <a:r>
+              <a:rPr lang="cs-CZ" altLang="cs-CZ" sz="2475" b="0" noProof="0" dirty="0">
+                <a:solidFill>
+                  <a:srgbClr val="142A3B"/>
+                </a:solidFill>
+                <a:latin typeface="Arial"/>
+                <a:ea typeface="Arial"/>
+                <a:cs typeface="Arial"/>
+              </a:rPr>
+              <a:t>5! = 120, 0! = 1</a:t>
+            </a:r>
+            <a:endParaRPr lang="cs-CZ" altLang="cs-CZ" sz="2475" noProof="0" dirty="0"/>
           </a:p>
         </p:txBody>
       </p:sp>
@@ -18925,8 +18971,8 @@
         </p:nvSpPr>
         <p:spPr>
           <a:xfrm>
-            <a:off x="838200" y="4667250"/>
-            <a:ext cx="7239000" cy="771525"/>
+            <a:off x="838200" y="6486790"/>
+            <a:ext cx="7239000" cy="1269823"/>
           </a:xfrm>
           <a:prstGeom prst="rect">
             <a:avLst/>
@@ -18941,17 +18987,59 @@
           <a:p>
             <a:pPr algn="l"/>
             <a:r>
-              <a:rPr lang="cs-CZ" altLang="cs-CZ" sz="2475" b="0" noProof="0">
-                <a:solidFill>
-                  <a:srgbClr val="142A3B"/>
-                </a:solidFill>
-                <a:latin typeface="Arial"/>
-                <a:ea typeface="Arial"/>
-                <a:cs typeface="Arial"/>
-              </a:rPr>
-              <a:t>Excel: KOMBINACE(5;2) = 10; FAKTORIÁL(5) = 120</a:t>
-            </a:r>
-            <a:endParaRPr lang="cs-CZ" altLang="cs-CZ" sz="2475" noProof="0"/>
+              <a:rPr lang="cs-CZ" altLang="cs-CZ" sz="2475" b="0" noProof="0" dirty="0">
+                <a:solidFill>
+                  <a:srgbClr val="142A3B"/>
+                </a:solidFill>
+                <a:latin typeface="Arial"/>
+                <a:ea typeface="Arial"/>
+                <a:cs typeface="Arial"/>
+              </a:rPr>
+              <a:t>Excel: </a:t>
+            </a:r>
+            <a:br>
+              <a:rPr lang="cs-CZ" altLang="cs-CZ" sz="2475" b="0" noProof="0" dirty="0">
+                <a:solidFill>
+                  <a:srgbClr val="142A3B"/>
+                </a:solidFill>
+                <a:latin typeface="Arial"/>
+                <a:ea typeface="Arial"/>
+                <a:cs typeface="Arial"/>
+              </a:rPr>
+            </a:br>
+            <a:r>
+              <a:rPr lang="cs-CZ" altLang="cs-CZ" sz="2475" b="0" noProof="0" dirty="0">
+                <a:solidFill>
+                  <a:srgbClr val="142A3B"/>
+                </a:solidFill>
+                <a:latin typeface="Arial"/>
+                <a:ea typeface="Arial"/>
+                <a:cs typeface="Arial"/>
+              </a:rPr>
+              <a:t>KOMBINACE(5;2) = 10; </a:t>
+            </a:r>
+            <a:br>
+              <a:rPr lang="cs-CZ" altLang="cs-CZ" sz="2475" b="0" noProof="0" dirty="0">
+                <a:solidFill>
+                  <a:srgbClr val="142A3B"/>
+                </a:solidFill>
+                <a:latin typeface="Arial"/>
+                <a:ea typeface="Arial"/>
+                <a:cs typeface="Arial"/>
+              </a:rPr>
+            </a:br>
+            <a:r>
+              <a:rPr lang="cs-CZ" altLang="cs-CZ" sz="2475" b="0" noProof="0" dirty="0">
+                <a:solidFill>
+                  <a:srgbClr val="142A3B"/>
+                </a:solidFill>
+                <a:latin typeface="Arial"/>
+                <a:ea typeface="Arial"/>
+                <a:cs typeface="Arial"/>
+              </a:rPr>
+              <a:t>FAKTORIÁL(5) = 120</a:t>
+            </a:r>
+            <a:endParaRPr lang="cs-CZ" altLang="cs-CZ" sz="2475" noProof="0" dirty="0"/>
           </a:p>
         </p:txBody>
       </p:sp>
@@ -20550,8 +20638,8 @@
         </p:blipFill>
         <p:spPr>
           <a:xfrm>
-            <a:off x="6648450" y="2016008"/>
-            <a:ext cx="7753350" cy="5445359"/>
+            <a:off x="5509846" y="1253011"/>
+            <a:ext cx="9730154" cy="6833714"/>
           </a:xfrm>
           <a:prstGeom prst="rect">
             <a:avLst/>
@@ -20904,7 +20992,7 @@
           <a:p>
             <a:pPr algn="l"/>
             <a:r>
-              <a:rPr lang="cs-CZ" altLang="cs-CZ" sz="2325" b="0" i="1" noProof="0">
+              <a:rPr lang="cs-CZ" altLang="cs-CZ" sz="2325" b="0" i="1" noProof="0" dirty="0">
                 <a:solidFill>
                   <a:srgbClr val="142A3B"/>
                 </a:solidFill>
@@ -20915,7 +21003,7 @@
               <a:t>n</a:t>
             </a:r>
             <a:r>
-              <a:rPr lang="cs-CZ" altLang="cs-CZ" sz="2325" b="0" noProof="0">
+              <a:rPr lang="cs-CZ" altLang="cs-CZ" sz="2325" b="0" noProof="0" dirty="0">
                 <a:solidFill>
                   <a:srgbClr val="142A3B"/>
                 </a:solidFill>
@@ -20925,7 +21013,7 @@
               </a:rPr>
               <a:t> = 5, π = 0,25: μ = 1,25; σ ≈ 0,97</a:t>
             </a:r>
-            <a:endParaRPr lang="cs-CZ" altLang="cs-CZ" sz="2325" noProof="0"/>
+            <a:endParaRPr lang="cs-CZ" altLang="cs-CZ" sz="2325" noProof="0" dirty="0"/>
           </a:p>
         </p:txBody>
       </p:sp>
@@ -20953,17 +21041,38 @@
           <a:p>
             <a:pPr algn="l"/>
             <a:r>
-              <a:rPr lang="cs-CZ" altLang="cs-CZ" sz="2325" b="0" noProof="0">
-                <a:solidFill>
-                  <a:srgbClr val="142A3B"/>
-                </a:solidFill>
-                <a:latin typeface="Arial"/>
-                <a:ea typeface="Arial"/>
-                <a:cs typeface="Arial"/>
-              </a:rPr>
-              <a:t>π = 0,5 souměrné; malé π doprava, velké doleva zešikmené</a:t>
-            </a:r>
-            <a:endParaRPr lang="cs-CZ" altLang="cs-CZ" sz="2325" noProof="0"/>
+              <a:rPr lang="cs-CZ" altLang="cs-CZ" sz="2325" b="0" noProof="0" dirty="0">
+                <a:solidFill>
+                  <a:srgbClr val="142A3B"/>
+                </a:solidFill>
+                <a:latin typeface="Arial"/>
+                <a:ea typeface="Arial"/>
+                <a:cs typeface="Arial"/>
+              </a:rPr>
+              <a:t>π = 0,5 souměrné; </a:t>
+            </a:r>
+            <a:br>
+              <a:rPr lang="cs-CZ" altLang="cs-CZ" sz="2325" b="0" noProof="0" dirty="0">
+                <a:solidFill>
+                  <a:srgbClr val="142A3B"/>
+                </a:solidFill>
+                <a:latin typeface="Arial"/>
+                <a:ea typeface="Arial"/>
+                <a:cs typeface="Arial"/>
+              </a:rPr>
+            </a:br>
+            <a:r>
+              <a:rPr lang="cs-CZ" altLang="cs-CZ" sz="2325" b="0" noProof="0" dirty="0">
+                <a:solidFill>
+                  <a:srgbClr val="142A3B"/>
+                </a:solidFill>
+                <a:latin typeface="Arial"/>
+                <a:ea typeface="Arial"/>
+                <a:cs typeface="Arial"/>
+              </a:rPr>
+              <a:t>malé π doprava, velké doleva zešikmené</a:t>
+            </a:r>
+            <a:endParaRPr lang="cs-CZ" altLang="cs-CZ" sz="2325" noProof="0" dirty="0"/>
           </a:p>
         </p:txBody>
       </p:sp>
@@ -20975,7 +21084,7 @@
         </p:nvSpPr>
         <p:spPr>
           <a:xfrm>
-            <a:off x="838200" y="5314950"/>
+            <a:off x="838200" y="5737347"/>
             <a:ext cx="5334000" cy="723900"/>
           </a:xfrm>
           <a:prstGeom prst="rect">
@@ -20991,7 +21100,7 @@
           <a:p>
             <a:pPr algn="l"/>
             <a:r>
-              <a:rPr lang="cs-CZ" altLang="cs-CZ" sz="2325" b="0" noProof="0">
+              <a:rPr lang="cs-CZ" altLang="cs-CZ" sz="2325" b="0" noProof="0" dirty="0">
                 <a:solidFill>
                   <a:srgbClr val="142A3B"/>
                 </a:solidFill>
@@ -21001,7 +21110,7 @@
               </a:rPr>
               <a:t>Víc pokusů: širší a souměrnější rozdělení</a:t>
             </a:r>
-            <a:endParaRPr lang="cs-CZ" altLang="cs-CZ" sz="2325" noProof="0"/>
+            <a:endParaRPr lang="cs-CZ" altLang="cs-CZ" sz="2325" noProof="0" dirty="0"/>
           </a:p>
         </p:txBody>
       </p:sp>
@@ -21286,7 +21395,7 @@
           <a:p>
             <a:pPr algn="l"/>
             <a:r>
-              <a:rPr lang="cs-CZ" altLang="cs-CZ" sz="2250" b="0" i="1" noProof="0">
+              <a:rPr lang="cs-CZ" altLang="cs-CZ" sz="2250" b="0" i="1" noProof="0" dirty="0">
                 <a:solidFill>
                   <a:srgbClr val="142A3B"/>
                 </a:solidFill>
@@ -21297,7 +21406,7 @@
               <a:t>P</a:t>
             </a:r>
             <a:r>
-              <a:rPr lang="cs-CZ" altLang="cs-CZ" sz="2250" b="0" noProof="0">
+              <a:rPr lang="cs-CZ" altLang="cs-CZ" sz="2250" b="0" noProof="0" dirty="0">
                 <a:solidFill>
                   <a:srgbClr val="142A3B"/>
                 </a:solidFill>
@@ -21308,7 +21417,7 @@
               <a:t>(</a:t>
             </a:r>
             <a:r>
-              <a:rPr lang="cs-CZ" altLang="cs-CZ" sz="2250" b="0" i="1" noProof="0">
+              <a:rPr lang="cs-CZ" altLang="cs-CZ" sz="2250" b="0" i="1" noProof="0" dirty="0">
                 <a:solidFill>
                   <a:srgbClr val="142A3B"/>
                 </a:solidFill>
@@ -21319,7 +21428,7 @@
               <a:t>X</a:t>
             </a:r>
             <a:r>
-              <a:rPr lang="cs-CZ" altLang="cs-CZ" sz="2250" b="0" noProof="0">
+              <a:rPr lang="cs-CZ" altLang="cs-CZ" sz="2250" b="0" noProof="0" dirty="0">
                 <a:solidFill>
                   <a:srgbClr val="142A3B"/>
                 </a:solidFill>
@@ -21330,7 +21439,7 @@
               <a:t> ≥ 10) = 1 − </a:t>
             </a:r>
             <a:r>
-              <a:rPr lang="cs-CZ" altLang="cs-CZ" sz="2250" b="0" i="1" noProof="0">
+              <a:rPr lang="cs-CZ" altLang="cs-CZ" sz="2250" b="0" i="1" noProof="0" dirty="0">
                 <a:solidFill>
                   <a:srgbClr val="142A3B"/>
                 </a:solidFill>
@@ -21341,7 +21450,7 @@
               <a:t>P</a:t>
             </a:r>
             <a:r>
-              <a:rPr lang="cs-CZ" altLang="cs-CZ" sz="2250" b="0" noProof="0">
+              <a:rPr lang="cs-CZ" altLang="cs-CZ" sz="2250" b="0" noProof="0" dirty="0">
                 <a:solidFill>
                   <a:srgbClr val="142A3B"/>
                 </a:solidFill>
@@ -21352,7 +21461,7 @@
               <a:t>(</a:t>
             </a:r>
             <a:r>
-              <a:rPr lang="cs-CZ" altLang="cs-CZ" sz="2250" b="0" i="1" noProof="0">
+              <a:rPr lang="cs-CZ" altLang="cs-CZ" sz="2250" b="0" i="1" noProof="0" dirty="0">
                 <a:solidFill>
                   <a:srgbClr val="142A3B"/>
                 </a:solidFill>
@@ -21363,7 +21472,7 @@
               <a:t>X</a:t>
             </a:r>
             <a:r>
-              <a:rPr lang="cs-CZ" altLang="cs-CZ" sz="2250" b="0" noProof="0">
+              <a:rPr lang="cs-CZ" altLang="cs-CZ" sz="2250" b="0" noProof="0" dirty="0">
                 <a:solidFill>
                   <a:srgbClr val="142A3B"/>
                 </a:solidFill>
@@ -21374,7 +21483,7 @@
               <a:t> ≤ 9) = </a:t>
             </a:r>
             <a:r>
-              <a:rPr lang="cs-CZ" altLang="cs-CZ" sz="2250" b="1" noProof="0">
+              <a:rPr lang="cs-CZ" altLang="cs-CZ" sz="2250" b="1" noProof="0" dirty="0">
                 <a:solidFill>
                   <a:srgbClr val="142A3B"/>
                 </a:solidFill>
@@ -21385,7 +21494,7 @@
               <a:t>0,014</a:t>
             </a:r>
             <a:r>
-              <a:rPr lang="cs-CZ" altLang="cs-CZ" sz="2250" b="0" noProof="0">
+              <a:rPr lang="cs-CZ" altLang="cs-CZ" sz="2250" b="0" noProof="0" dirty="0">
                 <a:solidFill>
                   <a:srgbClr val="142A3B"/>
                 </a:solidFill>
@@ -21395,7 +21504,7 @@
               </a:rPr>
               <a:t>; opačným jevem k „alespoň 10“ je „nejvýše 9“</a:t>
             </a:r>
-            <a:endParaRPr lang="cs-CZ" altLang="cs-CZ" sz="2250" noProof="0"/>
+            <a:endParaRPr lang="cs-CZ" altLang="cs-CZ" sz="2250" noProof="0" dirty="0"/>
           </a:p>
         </p:txBody>
       </p:sp>
@@ -21505,17 +21614,17 @@
           <a:p>
             <a:pPr algn="l"/>
             <a:r>
-              <a:rPr lang="cs-CZ" altLang="cs-CZ" sz="2250" b="0" i="1" noProof="0">
-                <a:solidFill>
-                  <a:srgbClr val="142A3B"/>
-                </a:solidFill>
-                <a:latin typeface="Arial"/>
-                <a:ea typeface="Arial"/>
-                <a:cs typeface="Arial"/>
-              </a:rPr>
-              <a:t>Je to P(výsledek | tipování), ne P(tipování | výsledek)</a:t>
-            </a:r>
-            <a:endParaRPr lang="cs-CZ" altLang="cs-CZ" sz="2250" noProof="0"/>
+              <a:rPr lang="cs-CZ" altLang="cs-CZ" sz="2250" b="0" i="1" noProof="0" dirty="0">
+                <a:solidFill>
+                  <a:srgbClr val="142A3B"/>
+                </a:solidFill>
+                <a:latin typeface="Arial"/>
+                <a:ea typeface="Arial"/>
+                <a:cs typeface="Arial"/>
+              </a:rPr>
+              <a:t>Je to P(výsledek | tipování), nikoli P(tipování | výsledek)</a:t>
+            </a:r>
+            <a:endParaRPr lang="cs-CZ" altLang="cs-CZ" sz="2250" noProof="0" dirty="0"/>
           </a:p>
         </p:txBody>
       </p:sp>
@@ -21535,8 +21644,8 @@
         </p:blipFill>
         <p:spPr>
           <a:xfrm>
-            <a:off x="2381250" y="3543300"/>
-            <a:ext cx="10477500" cy="4076700"/>
+            <a:off x="802805" y="3724275"/>
+            <a:ext cx="12913195" cy="4848225"/>
           </a:xfrm>
           <a:prstGeom prst="rect">
             <a:avLst/>
@@ -22465,8 +22574,8 @@
         </p:blipFill>
         <p:spPr>
           <a:xfrm>
-            <a:off x="2630714" y="3238500"/>
-            <a:ext cx="9978571" cy="4381500"/>
+            <a:off x="1221093" y="3093427"/>
+            <a:ext cx="12494907" cy="5486400"/>
           </a:xfrm>
           <a:prstGeom prst="rect">
             <a:avLst/>
@@ -23008,7 +23117,7 @@
           <a:p>
             <a:pPr algn="l"/>
             <a:r>
-              <a:rPr lang="cs-CZ" altLang="cs-CZ" sz="2850" b="0" i="1" noProof="0">
+              <a:rPr lang="cs-CZ" altLang="cs-CZ" sz="2850" b="0" i="1" noProof="0" dirty="0">
                 <a:solidFill>
                   <a:srgbClr val="142A3B"/>
                 </a:solidFill>
@@ -23019,7 +23128,7 @@
               <a:t>n</a:t>
             </a:r>
             <a:r>
-              <a:rPr lang="cs-CZ" altLang="cs-CZ" sz="2850" b="0" noProof="0">
+              <a:rPr lang="cs-CZ" altLang="cs-CZ" sz="2850" b="0" noProof="0" dirty="0">
                 <a:solidFill>
                   <a:srgbClr val="142A3B"/>
                 </a:solidFill>
@@ -23030,7 +23139,7 @@
               <a:t> = 50 → 0,069; 200 → 0,035; 800 → 0,017: </a:t>
             </a:r>
             <a:r>
-              <a:rPr lang="cs-CZ" altLang="cs-CZ" sz="2850" b="1" noProof="0">
+              <a:rPr lang="cs-CZ" altLang="cs-CZ" sz="2850" b="1" noProof="0" dirty="0">
                 <a:solidFill>
                   <a:srgbClr val="142A3B"/>
                 </a:solidFill>
@@ -23040,7 +23149,7 @@
               </a:rPr>
               <a:t>čtyřnásobek pokusů půlí kolísání</a:t>
             </a:r>
-            <a:endParaRPr lang="cs-CZ" altLang="cs-CZ" sz="2850" noProof="0"/>
+            <a:endParaRPr lang="cs-CZ" altLang="cs-CZ" sz="2850" noProof="0" dirty="0"/>
           </a:p>
         </p:txBody>
       </p:sp>
@@ -26952,8 +27061,8 @@
         </p:blipFill>
         <p:spPr>
           <a:xfrm>
-            <a:off x="2402943" y="3038475"/>
-            <a:ext cx="10434115" cy="4581525"/>
+            <a:off x="2402942" y="3038475"/>
+            <a:ext cx="11497050" cy="5048250"/>
           </a:xfrm>
           <a:prstGeom prst="rect">
             <a:avLst/>
@@ -26968,7 +27077,7 @@
         </p:nvSpPr>
         <p:spPr>
           <a:xfrm>
-            <a:off x="838200" y="7696200"/>
+            <a:off x="627185" y="8001000"/>
             <a:ext cx="12382500" cy="285750"/>
           </a:xfrm>
           <a:prstGeom prst="rect">
@@ -26984,7 +27093,7 @@
           <a:p>
             <a:pPr algn="l"/>
             <a:r>
-              <a:rPr lang="cs-CZ" altLang="cs-CZ" sz="1650" b="0" noProof="0">
+              <a:rPr lang="cs-CZ" altLang="cs-CZ" sz="1650" b="0" noProof="0" dirty="0">
                 <a:solidFill>
                   <a:srgbClr val="576574"/>
                 </a:solidFill>
@@ -26994,7 +27103,7 @@
               </a:rPr>
               <a:t>Simulovaná data</a:t>
             </a:r>
-            <a:endParaRPr lang="cs-CZ" altLang="cs-CZ" sz="1650" noProof="0"/>
+            <a:endParaRPr lang="cs-CZ" altLang="cs-CZ" sz="1650" noProof="0" dirty="0"/>
           </a:p>
         </p:txBody>
       </p:sp>
@@ -27232,8 +27341,8 @@
         </p:blipFill>
         <p:spPr>
           <a:xfrm>
-            <a:off x="7410450" y="2463079"/>
-            <a:ext cx="6991350" cy="4551217"/>
+            <a:off x="6806084" y="1526814"/>
+            <a:ext cx="8433916" cy="5490296"/>
           </a:xfrm>
           <a:prstGeom prst="rect">
             <a:avLst/>
@@ -27313,7 +27422,7 @@
           <a:p>
             <a:pPr algn="l"/>
             <a:r>
-              <a:rPr lang="cs-CZ" altLang="cs-CZ" sz="2100" b="1" noProof="0">
+              <a:rPr lang="cs-CZ" altLang="cs-CZ" sz="2100" b="1" noProof="0" dirty="0">
                 <a:solidFill>
                   <a:srgbClr val="142A3B"/>
                 </a:solidFill>
@@ -27324,7 +27433,7 @@
               <a:t>Výsledek:</a:t>
             </a:r>
             <a:r>
-              <a:rPr lang="cs-CZ" altLang="cs-CZ" sz="2100" b="0" noProof="0">
+              <a:rPr lang="cs-CZ" altLang="cs-CZ" sz="2100" b="0" noProof="0" dirty="0">
                 <a:solidFill>
                   <a:srgbClr val="142A3B"/>
                 </a:solidFill>
@@ -27334,8 +27443,18 @@
               </a:rPr>
               <a:t> konkrétní kartička; </a:t>
             </a:r>
-            <a:r>
-              <a:rPr lang="cs-CZ" altLang="cs-CZ" sz="2100" b="1" noProof="0">
+            <a:br>
+              <a:rPr lang="cs-CZ" altLang="cs-CZ" sz="2100" b="0" noProof="0" dirty="0">
+                <a:solidFill>
+                  <a:srgbClr val="142A3B"/>
+                </a:solidFill>
+                <a:latin typeface="Arial"/>
+                <a:ea typeface="Arial"/>
+                <a:cs typeface="Arial"/>
+              </a:rPr>
+            </a:br>
+            <a:r>
+              <a:rPr lang="cs-CZ" altLang="cs-CZ" sz="2100" b="1" noProof="0" dirty="0">
                 <a:solidFill>
                   <a:srgbClr val="142A3B"/>
                 </a:solidFill>
@@ -27346,7 +27465,7 @@
               <a:t>výběrový prostor:</a:t>
             </a:r>
             <a:r>
-              <a:rPr lang="cs-CZ" altLang="cs-CZ" sz="2100" b="0" noProof="0">
+              <a:rPr lang="cs-CZ" altLang="cs-CZ" sz="2100" b="0" noProof="0" dirty="0">
                 <a:solidFill>
                   <a:srgbClr val="142A3B"/>
                 </a:solidFill>
@@ -27356,7 +27475,7 @@
               </a:rPr>
               <a:t> všech 100 kartiček</a:t>
             </a:r>
-            <a:endParaRPr lang="cs-CZ" altLang="cs-CZ" sz="2100" noProof="0"/>
+            <a:endParaRPr lang="cs-CZ" altLang="cs-CZ" sz="2100" noProof="0" dirty="0"/>
           </a:p>
         </p:txBody>
       </p:sp>
@@ -27384,7 +27503,7 @@
           <a:p>
             <a:pPr algn="l"/>
             <a:r>
-              <a:rPr lang="cs-CZ" altLang="cs-CZ" sz="2100" b="1" noProof="0">
+              <a:rPr lang="cs-CZ" altLang="cs-CZ" sz="2100" b="1" noProof="0" dirty="0">
                 <a:solidFill>
                   <a:srgbClr val="142A3B"/>
                 </a:solidFill>
@@ -27395,7 +27514,7 @@
               <a:t>Jev:</a:t>
             </a:r>
             <a:r>
-              <a:rPr lang="cs-CZ" altLang="cs-CZ" sz="2100" b="0" noProof="0">
+              <a:rPr lang="cs-CZ" altLang="cs-CZ" sz="2100" b="0" noProof="0" dirty="0">
                 <a:solidFill>
                   <a:srgbClr val="142A3B"/>
                 </a:solidFill>
@@ -27405,7 +27524,7 @@
               </a:rPr>
               <a:t> množina výsledků se společnou vlastností, např. „podstatné jméno“ (40 kartiček)</a:t>
             </a:r>
-            <a:endParaRPr lang="cs-CZ" altLang="cs-CZ" sz="2100" noProof="0"/>
+            <a:endParaRPr lang="cs-CZ" altLang="cs-CZ" sz="2100" noProof="0" dirty="0"/>
           </a:p>
         </p:txBody>
       </p:sp>
@@ -27433,7 +27552,7 @@
           <a:p>
             <a:pPr algn="l"/>
             <a:r>
-              <a:rPr lang="cs-CZ" altLang="cs-CZ" sz="2100" b="0" i="1" noProof="0">
+              <a:rPr lang="cs-CZ" altLang="cs-CZ" sz="2100" b="0" i="1" noProof="0" dirty="0">
                 <a:solidFill>
                   <a:srgbClr val="142A3B"/>
                 </a:solidFill>
@@ -27444,7 +27563,7 @@
               <a:t>P</a:t>
             </a:r>
             <a:r>
-              <a:rPr lang="cs-CZ" altLang="cs-CZ" sz="2100" b="0" noProof="0">
+              <a:rPr lang="cs-CZ" altLang="cs-CZ" sz="2100" b="0" noProof="0" dirty="0">
                 <a:solidFill>
                   <a:srgbClr val="142A3B"/>
                 </a:solidFill>
@@ -27454,7 +27573,7 @@
               </a:rPr>
               <a:t>(podstatné jméno) = 40/100 = 0,40</a:t>
             </a:r>
-            <a:endParaRPr lang="cs-CZ" altLang="cs-CZ" sz="2100" noProof="0"/>
+            <a:endParaRPr lang="cs-CZ" altLang="cs-CZ" sz="2100" noProof="0" dirty="0"/>
           </a:p>
         </p:txBody>
       </p:sp>
@@ -27482,7 +27601,7 @@
           <a:p>
             <a:pPr algn="l"/>
             <a:r>
-              <a:rPr lang="cs-CZ" altLang="cs-CZ" sz="2100" b="0" i="1" noProof="0">
+              <a:rPr lang="cs-CZ" altLang="cs-CZ" sz="2100" b="0" i="1" noProof="0" dirty="0">
                 <a:solidFill>
                   <a:srgbClr val="142A3B"/>
                 </a:solidFill>
@@ -27493,7 +27612,7 @@
               <a:t>Podíl jen pro stejně pravděpodobné výsledky:</a:t>
             </a:r>
             <a:r>
-              <a:rPr lang="cs-CZ" altLang="cs-CZ" sz="2100" b="0" noProof="0">
+              <a:rPr lang="cs-CZ" altLang="cs-CZ" sz="2100" b="0" noProof="0" dirty="0">
                 <a:solidFill>
                   <a:srgbClr val="142A3B"/>
                 </a:solidFill>
@@ -27503,7 +27622,7 @@
               </a:rPr>
               <a:t> kartičky ano, slovní druhy ne</a:t>
             </a:r>
-            <a:endParaRPr lang="cs-CZ" altLang="cs-CZ" sz="2100" noProof="0"/>
+            <a:endParaRPr lang="cs-CZ" altLang="cs-CZ" sz="2100" noProof="0" dirty="0"/>
           </a:p>
         </p:txBody>
       </p:sp>

</xml_diff>